<commit_message>
Drop the AI label from the lesson images and slides
The corner badge on the explainer images and the labels on the deck
covers and step dividers are gone, and the falling-apple caption no
longer mentions how the scene was made. Decks and the bundle rebuilt.

Co-Authored-By: Claude Opus 5.5 <noreply@anthropic.com>
</commit_message>
<xml_diff>
--- a/dist/sunum/cembersel-hareket.pptx
+++ b/dist/sunum/cembersel-hareket.pptx
@@ -4668,7 +4668,7 @@
       </p:grpSpPr>
       <p:pic>
         <p:nvPicPr>
-          <p:cNvPr id="2" name="Image 0" descr="/tmp/claude-1000/-opt-dersler/8a8328c3-841c-44fa-b76f-82572d338d3d/scratchpad/d4/sek/cembersel-hareket-kapak.jpg">    </p:cNvPr>
+          <p:cNvPr id="2" name="Image 0" descr="/tmp/claude-1000/-opt-dersler/8a8328c3-841c-44fa-b76f-82572d338d3d/scratchpad/d5/sek/cembersel-hareket-kapak.jpg">    </p:cNvPr>
           <p:cNvPicPr>
             <a:picLocks noChangeAspect="1"/>
           </p:cNvPicPr>
@@ -5321,69 +5321,6 @@
         </p:nvSpPr>
         <p:spPr>
           <a:xfrm>
-            <a:off x="9448495" y="6309360"/>
-            <a:ext cx="2103120" cy="274320"/>
-          </a:xfrm>
-          <a:prstGeom prst="roundRect">
-            <a:avLst>
-              <a:gd name="adj" fmla="val 50000"/>
-            </a:avLst>
-          </a:prstGeom>
-          <a:solidFill>
-            <a:srgbClr val="0E1426">
-              <a:alpha val="65000"/>
-            </a:srgbClr>
-          </a:solidFill>
-          <a:ln/>
-        </p:spPr>
-      </p:sp>
-      <p:sp>
-        <p:nvSpPr>
-          <p:cNvPr id="22" name="Text 19"/>
-          <p:cNvSpPr txBox="1"/>
-          <p:nvPr/>
-        </p:nvSpPr>
-        <p:spPr>
-          <a:xfrm>
-            <a:off x="9448495" y="6309360"/>
-            <a:ext cx="2103120" cy="274320"/>
-          </a:xfrm>
-          <a:prstGeom prst="rect">
-            <a:avLst/>
-          </a:prstGeom>
-          <a:noFill/>
-          <a:ln/>
-        </p:spPr>
-        <p:txBody>
-          <a:bodyPr wrap="square" lIns="0" tIns="0" rIns="0" bIns="0" rtlCol="0" anchor="ctr"/>
-          <a:lstStyle/>
-          <a:p>
-            <a:pPr algn="ctr" indent="0" marL="0">
-              <a:buNone/>
-            </a:pPr>
-            <a:r>
-              <a:rPr lang="en-US" sz="900" dirty="0">
-                <a:solidFill>
-                  <a:srgbClr val="E4E9F5"/>
-                </a:solidFill>
-                <a:latin typeface="Calibri" pitchFamily="34" charset="0"/>
-                <a:ea typeface="Calibri" pitchFamily="34" charset="-122"/>
-                <a:cs typeface="Calibri" pitchFamily="34" charset="-120"/>
-              </a:rPr>
-              <a:t>Görsel: yapay zekâ ile üretildi</a:t>
-            </a:r>
-            <a:endParaRPr lang="en-US" sz="900" dirty="0"/>
-          </a:p>
-        </p:txBody>
-      </p:sp>
-      <p:sp>
-        <p:nvSpPr>
-          <p:cNvPr id="23" name="Shape 20"/>
-          <p:cNvSpPr/>
-          <p:nvPr/>
-        </p:nvSpPr>
-        <p:spPr>
-          <a:xfrm>
             <a:off x="640080" y="6382512"/>
             <a:ext cx="128016" cy="128016"/>
           </a:xfrm>
@@ -5400,7 +5337,7 @@
       </p:sp>
       <p:sp>
         <p:nvSpPr>
-          <p:cNvPr id="24" name="Text 21"/>
+          <p:cNvPr id="22" name="Text 19"/>
           <p:cNvSpPr txBox="1"/>
           <p:nvPr/>
         </p:nvSpPr>
@@ -6919,7 +6856,7 @@
       </p:sp>
       <p:pic>
         <p:nvPicPr>
-          <p:cNvPr id="14" name="Image 0" descr="/tmp/claude-1000/-opt-dersler/8a8328c3-841c-44fa-b76f-82572d338d3d/scratchpad/d4/sek/cembersel-hareket-03.png">    </p:cNvPr>
+          <p:cNvPr id="14" name="Image 0" descr="/tmp/claude-1000/-opt-dersler/8a8328c3-841c-44fa-b76f-82572d338d3d/scratchpad/d5/sek/cembersel-hareket-03.png">    </p:cNvPr>
           <p:cNvPicPr>
             <a:picLocks noChangeAspect="1"/>
           </p:cNvPicPr>
@@ -8901,7 +8838,7 @@
       </p:sp>
       <p:pic>
         <p:nvPicPr>
-          <p:cNvPr id="17" name="Image 0" descr="/tmp/claude-1000/-opt-dersler/8a8328c3-841c-44fa-b76f-82572d338d3d/scratchpad/d4/sek/cembersel-hareket-04.png">    </p:cNvPr>
+          <p:cNvPr id="17" name="Image 0" descr="/tmp/claude-1000/-opt-dersler/8a8328c3-841c-44fa-b76f-82572d338d3d/scratchpad/d5/sek/cembersel-hareket-04.png">    </p:cNvPr>
           <p:cNvPicPr>
             <a:picLocks noChangeAspect="1"/>
           </p:cNvPicPr>
@@ -10776,7 +10713,7 @@
       </p:sp>
       <p:pic>
         <p:nvPicPr>
-          <p:cNvPr id="17" name="Image 0" descr="/tmp/claude-1000/-opt-dersler/8a8328c3-841c-44fa-b76f-82572d338d3d/scratchpad/d4/sek/cembersel-hareket-05.png">    </p:cNvPr>
+          <p:cNvPr id="17" name="Image 0" descr="/tmp/claude-1000/-opt-dersler/8a8328c3-841c-44fa-b76f-82572d338d3d/scratchpad/d5/sek/cembersel-hareket-05.png">    </p:cNvPr>
           <p:cNvPicPr>
             <a:picLocks noChangeAspect="1"/>
           </p:cNvPicPr>
@@ -12722,7 +12659,7 @@
       </p:sp>
       <p:pic>
         <p:nvPicPr>
-          <p:cNvPr id="18" name="Image 0" descr="/tmp/claude-1000/-opt-dersler/8a8328c3-841c-44fa-b76f-82572d338d3d/scratchpad/d4/sek/cembersel-hareket-06.png">    </p:cNvPr>
+          <p:cNvPr id="18" name="Image 0" descr="/tmp/claude-1000/-opt-dersler/8a8328c3-841c-44fa-b76f-82572d338d3d/scratchpad/d5/sek/cembersel-hareket-06.png">    </p:cNvPr>
           <p:cNvPicPr>
             <a:picLocks noChangeAspect="1"/>
           </p:cNvPicPr>
@@ -16389,7 +16326,7 @@
       </p:sp>
       <p:pic>
         <p:nvPicPr>
-          <p:cNvPr id="11" name="Image 0" descr="/tmp/claude-1000/-opt-dersler/8a8328c3-841c-44fa-b76f-82572d338d3d/scratchpad/d4/sek/cembersel-hareket-uygulama-kart.jpg">    </p:cNvPr>
+          <p:cNvPr id="11" name="Image 0" descr="/tmp/claude-1000/-opt-dersler/8a8328c3-841c-44fa-b76f-82572d338d3d/scratchpad/d5/sek/cembersel-hareket-uygulama-kart.jpg">    </p:cNvPr>
           <p:cNvPicPr>
             <a:picLocks noChangeAspect="1"/>
           </p:cNvPicPr>
@@ -16413,70 +16350,7 @@
       </p:pic>
       <p:sp>
         <p:nvSpPr>
-          <p:cNvPr id="12" name="Shape 9"/>
-          <p:cNvSpPr/>
-          <p:nvPr/>
-        </p:nvSpPr>
-        <p:spPr>
-          <a:xfrm>
-            <a:off x="9704527" y="4198925"/>
-            <a:ext cx="1755648" cy="246888"/>
-          </a:xfrm>
-          <a:prstGeom prst="roundRect">
-            <a:avLst>
-              <a:gd name="adj" fmla="val 48148"/>
-            </a:avLst>
-          </a:prstGeom>
-          <a:solidFill>
-            <a:srgbClr val="0E1426">
-              <a:alpha val="60000"/>
-            </a:srgbClr>
-          </a:solidFill>
-          <a:ln/>
-        </p:spPr>
-      </p:sp>
-      <p:sp>
-        <p:nvSpPr>
-          <p:cNvPr id="13" name="Text 10"/>
-          <p:cNvSpPr txBox="1"/>
-          <p:nvPr/>
-        </p:nvSpPr>
-        <p:spPr>
-          <a:xfrm>
-            <a:off x="9704527" y="4198925"/>
-            <a:ext cx="1755648" cy="246888"/>
-          </a:xfrm>
-          <a:prstGeom prst="rect">
-            <a:avLst/>
-          </a:prstGeom>
-          <a:noFill/>
-          <a:ln/>
-        </p:spPr>
-        <p:txBody>
-          <a:bodyPr wrap="square" lIns="0" tIns="0" rIns="0" bIns="0" rtlCol="0" anchor="ctr"/>
-          <a:lstStyle/>
-          <a:p>
-            <a:pPr algn="ctr" indent="0" marL="0">
-              <a:buNone/>
-            </a:pPr>
-            <a:r>
-              <a:rPr lang="en-US" sz="850" dirty="0">
-                <a:solidFill>
-                  <a:srgbClr val="FFFFFF"/>
-                </a:solidFill>
-                <a:latin typeface="Calibri" pitchFamily="34" charset="0"/>
-                <a:ea typeface="Calibri" pitchFamily="34" charset="-122"/>
-                <a:cs typeface="Calibri" pitchFamily="34" charset="-120"/>
-              </a:rPr>
-              <a:t>Yapay zekâ ile üretildi</a:t>
-            </a:r>
-            <a:endParaRPr lang="en-US" sz="850" dirty="0"/>
-          </a:p>
-        </p:txBody>
-      </p:sp>
-      <p:sp>
-        <p:nvSpPr>
-          <p:cNvPr id="14" name="Text 11"/>
+          <p:cNvPr id="12" name="Text 9"/>
           <p:cNvSpPr txBox="1"/>
           <p:nvPr/>
         </p:nvSpPr>
@@ -16552,7 +16426,7 @@
       </p:sp>
       <p:sp>
         <p:nvSpPr>
-          <p:cNvPr id="15" name="Shape 12"/>
+          <p:cNvPr id="13" name="Shape 10"/>
           <p:cNvSpPr/>
           <p:nvPr/>
         </p:nvSpPr>
@@ -16574,7 +16448,7 @@
       </p:sp>
       <p:sp>
         <p:nvSpPr>
-          <p:cNvPr id="16" name="Text 13"/>
+          <p:cNvPr id="14" name="Text 11"/>
           <p:cNvSpPr txBox="1"/>
           <p:nvPr/>
         </p:nvSpPr>
@@ -16613,7 +16487,7 @@
       </p:sp>
       <p:sp>
         <p:nvSpPr>
-          <p:cNvPr id="17" name="Text 14"/>
+          <p:cNvPr id="15" name="Text 12"/>
           <p:cNvSpPr txBox="1"/>
           <p:nvPr/>
         </p:nvSpPr>
@@ -20315,7 +20189,7 @@
       </p:sp>
       <p:pic>
         <p:nvPicPr>
-          <p:cNvPr id="15" name="Image 0" descr="/tmp/claude-1000/-opt-dersler/8a8328c3-841c-44fa-b76f-82572d338d3d/scratchpad/d4/sek/cembersel-hareket-07.png">    </p:cNvPr>
+          <p:cNvPr id="15" name="Image 0" descr="/tmp/claude-1000/-opt-dersler/8a8328c3-841c-44fa-b76f-82572d338d3d/scratchpad/d5/sek/cembersel-hareket-07.png">    </p:cNvPr>
           <p:cNvPicPr>
             <a:picLocks noChangeAspect="1"/>
           </p:cNvPicPr>
@@ -35965,7 +35839,7 @@
       </p:sp>
       <p:pic>
         <p:nvPicPr>
-          <p:cNvPr id="11" name="Image 0" descr="/tmp/claude-1000/-opt-dersler/8a8328c3-841c-44fa-b76f-82572d338d3d/scratchpad/d4/sek/cembersel-hareket-gunluk-kart.jpg">    </p:cNvPr>
+          <p:cNvPr id="11" name="Image 0" descr="/tmp/claude-1000/-opt-dersler/8a8328c3-841c-44fa-b76f-82572d338d3d/scratchpad/d5/sek/cembersel-hareket-gunluk-kart.jpg">    </p:cNvPr>
           <p:cNvPicPr>
             <a:picLocks noChangeAspect="1"/>
           </p:cNvPicPr>
@@ -35989,70 +35863,7 @@
       </p:pic>
       <p:sp>
         <p:nvSpPr>
-          <p:cNvPr id="12" name="Shape 9"/>
-          <p:cNvSpPr/>
-          <p:nvPr/>
-        </p:nvSpPr>
-        <p:spPr>
-          <a:xfrm>
-            <a:off x="9704527" y="4198925"/>
-            <a:ext cx="1755648" cy="246888"/>
-          </a:xfrm>
-          <a:prstGeom prst="roundRect">
-            <a:avLst>
-              <a:gd name="adj" fmla="val 48148"/>
-            </a:avLst>
-          </a:prstGeom>
-          <a:solidFill>
-            <a:srgbClr val="0E1426">
-              <a:alpha val="60000"/>
-            </a:srgbClr>
-          </a:solidFill>
-          <a:ln/>
-        </p:spPr>
-      </p:sp>
-      <p:sp>
-        <p:nvSpPr>
-          <p:cNvPr id="13" name="Text 10"/>
-          <p:cNvSpPr txBox="1"/>
-          <p:nvPr/>
-        </p:nvSpPr>
-        <p:spPr>
-          <a:xfrm>
-            <a:off x="9704527" y="4198925"/>
-            <a:ext cx="1755648" cy="246888"/>
-          </a:xfrm>
-          <a:prstGeom prst="rect">
-            <a:avLst/>
-          </a:prstGeom>
-          <a:noFill/>
-          <a:ln/>
-        </p:spPr>
-        <p:txBody>
-          <a:bodyPr wrap="square" lIns="0" tIns="0" rIns="0" bIns="0" rtlCol="0" anchor="ctr"/>
-          <a:lstStyle/>
-          <a:p>
-            <a:pPr algn="ctr" indent="0" marL="0">
-              <a:buNone/>
-            </a:pPr>
-            <a:r>
-              <a:rPr lang="en-US" sz="850" dirty="0">
-                <a:solidFill>
-                  <a:srgbClr val="FFFFFF"/>
-                </a:solidFill>
-                <a:latin typeface="Calibri" pitchFamily="34" charset="0"/>
-                <a:ea typeface="Calibri" pitchFamily="34" charset="-122"/>
-                <a:cs typeface="Calibri" pitchFamily="34" charset="-120"/>
-              </a:rPr>
-              <a:t>Yapay zekâ ile üretildi</a:t>
-            </a:r>
-            <a:endParaRPr lang="en-US" sz="850" dirty="0"/>
-          </a:p>
-        </p:txBody>
-      </p:sp>
-      <p:sp>
-        <p:nvSpPr>
-          <p:cNvPr id="14" name="Text 11"/>
+          <p:cNvPr id="12" name="Text 9"/>
           <p:cNvSpPr txBox="1"/>
           <p:nvPr/>
         </p:nvSpPr>
@@ -36162,7 +35973,7 @@
       </p:sp>
       <p:sp>
         <p:nvSpPr>
-          <p:cNvPr id="15" name="Shape 12"/>
+          <p:cNvPr id="13" name="Shape 10"/>
           <p:cNvSpPr/>
           <p:nvPr/>
         </p:nvSpPr>
@@ -36184,7 +35995,7 @@
       </p:sp>
       <p:sp>
         <p:nvSpPr>
-          <p:cNvPr id="16" name="Text 13"/>
+          <p:cNvPr id="14" name="Text 11"/>
           <p:cNvSpPr txBox="1"/>
           <p:nvPr/>
         </p:nvSpPr>
@@ -36223,7 +36034,7 @@
       </p:sp>
       <p:sp>
         <p:nvSpPr>
-          <p:cNvPr id="17" name="Text 14"/>
+          <p:cNvPr id="15" name="Text 12"/>
           <p:cNvSpPr txBox="1"/>
           <p:nvPr/>
         </p:nvSpPr>
@@ -40755,7 +40566,7 @@
       </p:sp>
       <p:pic>
         <p:nvPicPr>
-          <p:cNvPr id="14" name="Image 0" descr="/tmp/claude-1000/-opt-dersler/8a8328c3-841c-44fa-b76f-82572d338d3d/scratchpad/d4/sek/cembersel-hareket-01.png">    </p:cNvPr>
+          <p:cNvPr id="14" name="Image 0" descr="/tmp/claude-1000/-opt-dersler/8a8328c3-841c-44fa-b76f-82572d338d3d/scratchpad/d5/sek/cembersel-hareket-01.png">    </p:cNvPr>
           <p:cNvPicPr>
             <a:picLocks noChangeAspect="1"/>
           </p:cNvPicPr>
@@ -42520,7 +42331,7 @@
       </p:sp>
       <p:pic>
         <p:nvPicPr>
-          <p:cNvPr id="15" name="Image 0" descr="/tmp/claude-1000/-opt-dersler/8a8328c3-841c-44fa-b76f-82572d338d3d/scratchpad/d4/sek/cembersel-hareket-02.png">    </p:cNvPr>
+          <p:cNvPr id="15" name="Image 0" descr="/tmp/claude-1000/-opt-dersler/8a8328c3-841c-44fa-b76f-82572d338d3d/scratchpad/d5/sek/cembersel-hareket-02.png">    </p:cNvPr>
           <p:cNvPicPr>
             <a:picLocks noChangeAspect="1"/>
           </p:cNvPicPr>

</xml_diff>